<commit_message>
refactor: migrate project to leaf-only PlantVillage workflow
</commit_message>
<xml_diff>
--- a/deliverables/presentation/课程大作业汇报_叶片分类_CBAM.pptx
+++ b/deliverables/presentation/课程大作业汇报_叶片分类_CBAM.pptx
@@ -1,21 +1,22 @@
 
 <file path=ppt/presentation.xml><?xml version="1.0" encoding="utf-8"?>
-<p:presentation xmlns:a="http://schemas.openxmlformats.org/drawingml/2006/main" xmlns:r="http://schemas.openxmlformats.org/officeDocument/2006/relationships" xmlns:p="http://schemas.openxmlformats.org/presentationml/2006/main" autoCompressPictures="0">
+<p:presentation xmlns:a="http://schemas.openxmlformats.org/drawingml/2006/main" xmlns:r="http://schemas.openxmlformats.org/officeDocument/2006/relationships" xmlns:p="http://schemas.openxmlformats.org/presentationml/2006/main" saveSubsetFonts="1" autoCompressPictures="0">
   <p:sldMasterIdLst>
     <p:sldMasterId id="2147483648" r:id="rId1"/>
   </p:sldMasterIdLst>
   <p:sldIdLst>
-    <p:sldId id="256" r:id="rId3"/>
-    <p:sldId id="257" r:id="rId4"/>
-    <p:sldId id="258" r:id="rId5"/>
-    <p:sldId id="259" r:id="rId6"/>
-    <p:sldId id="260" r:id="rId7"/>
-    <p:sldId id="261" r:id="rId8"/>
-    <p:sldId id="262" r:id="rId9"/>
-    <p:sldId id="263" r:id="rId10"/>
-    <p:sldId id="264" r:id="rId11"/>
+    <p:sldId id="256" r:id="rId7"/>
+    <p:sldId id="257" r:id="rId8"/>
+    <p:sldId id="258" r:id="rId9"/>
+    <p:sldId id="259" r:id="rId10"/>
+    <p:sldId id="260" r:id="rId11"/>
+    <p:sldId id="261" r:id="rId12"/>
+    <p:sldId id="262" r:id="rId13"/>
+    <p:sldId id="263" r:id="rId14"/>
+    <p:sldId id="264" r:id="rId15"/>
+    <p:sldId id="265" r:id="rId16"/>
   </p:sldIdLst>
-  <p:sldSz cx="12191365" cy="6858000" type="screen4x3"/>
+  <p:sldSz cx="12191695" cy="6858000" type="screen4x3"/>
   <p:notesSz cx="6858000" cy="9144000"/>
   <p:defaultTextStyle>
     <a:defPPr>
@@ -112,22 +113,6 @@
       </a:defRPr>
     </a:lvl9pPr>
   </p:defaultTextStyle>
-  <p:extLst>
-    <p:ext uri="{EFAFB233-063F-42B5-8137-9DF3F51BA10A}">
-      <p15:sldGuideLst xmlns:p15="http://schemas.microsoft.com/office/powerpoint/2012/main">
-        <p15:guide id="1" orient="horz" pos="2160" userDrawn="1">
-          <p15:clr>
-            <a:srgbClr val="A4A3A4"/>
-          </p15:clr>
-        </p15:guide>
-        <p15:guide id="2" pos="2880" userDrawn="1">
-          <p15:clr>
-            <a:srgbClr val="A4A3A4"/>
-          </p15:clr>
-        </p15:guide>
-      </p15:sldGuideLst>
-    </p:ext>
-  </p:extLst>
 </p:presentation>
 </file>
 
@@ -312,6 +297,7 @@
           <a:p>
             <a:fld id="{5BCAD085-E8A6-8845-BD4E-CB4CCA059FC4}" type="datetimeFigureOut">
               <a:rPr lang="en-US" smtClean="0"/>
+              <a:t>1/27/13</a:t>
             </a:fld>
             <a:endParaRPr lang="en-US"/>
           </a:p>
@@ -353,12 +339,18 @@
           <a:p>
             <a:fld id="{C1FF6DA9-008F-8B48-92A6-B652298478BF}" type="slidenum">
               <a:rPr lang="en-US" smtClean="0"/>
+              <a:t>‹#›</a:t>
             </a:fld>
             <a:endParaRPr lang="en-US"/>
           </a:p>
         </p:txBody>
       </p:sp>
     </p:spTree>
+    <p:extLst>
+      <p:ext uri="{BB962C8B-B14F-4D97-AF65-F5344CB8AC3E}">
+        <p14:creationId xmlns:p14="http://schemas.microsoft.com/office/powerpoint/2010/main" val="3168075583"/>
+      </p:ext>
+    </p:extLst>
   </p:cSld>
   <p:clrMapOvr>
     <a:masterClrMapping/>
@@ -426,7 +418,6 @@
               <a:rPr lang="en-US" smtClean="0"/>
               <a:t>Click to edit Master text styles</a:t>
             </a:r>
-            <a:endParaRPr lang="en-US" smtClean="0"/>
           </a:p>
           <a:p>
             <a:pPr lvl="1"/>
@@ -434,7 +425,6 @@
               <a:rPr lang="en-US" smtClean="0"/>
               <a:t>Second level</a:t>
             </a:r>
-            <a:endParaRPr lang="en-US" smtClean="0"/>
           </a:p>
           <a:p>
             <a:pPr lvl="2"/>
@@ -442,7 +432,6 @@
               <a:rPr lang="en-US" smtClean="0"/>
               <a:t>Third level</a:t>
             </a:r>
-            <a:endParaRPr lang="en-US" smtClean="0"/>
           </a:p>
           <a:p>
             <a:pPr lvl="3"/>
@@ -450,7 +439,6 @@
               <a:rPr lang="en-US" smtClean="0"/>
               <a:t>Fourth level</a:t>
             </a:r>
-            <a:endParaRPr lang="en-US" smtClean="0"/>
           </a:p>
           <a:p>
             <a:pPr lvl="4"/>
@@ -479,6 +467,7 @@
           <a:p>
             <a:fld id="{5BCAD085-E8A6-8845-BD4E-CB4CCA059FC4}" type="datetimeFigureOut">
               <a:rPr lang="en-US" smtClean="0"/>
+              <a:t>1/27/13</a:t>
             </a:fld>
             <a:endParaRPr lang="en-US"/>
           </a:p>
@@ -520,12 +509,18 @@
           <a:p>
             <a:fld id="{C1FF6DA9-008F-8B48-92A6-B652298478BF}" type="slidenum">
               <a:rPr lang="en-US" smtClean="0"/>
+              <a:t>‹#›</a:t>
             </a:fld>
             <a:endParaRPr lang="en-US"/>
           </a:p>
         </p:txBody>
       </p:sp>
     </p:spTree>
+    <p:extLst>
+      <p:ext uri="{BB962C8B-B14F-4D97-AF65-F5344CB8AC3E}">
+        <p14:creationId xmlns:p14="http://schemas.microsoft.com/office/powerpoint/2010/main" val="2910927964"/>
+      </p:ext>
+    </p:extLst>
   </p:cSld>
   <p:clrMapOvr>
     <a:masterClrMapping/>
@@ -603,7 +598,6 @@
               <a:rPr lang="en-US" smtClean="0"/>
               <a:t>Click to edit Master text styles</a:t>
             </a:r>
-            <a:endParaRPr lang="en-US" smtClean="0"/>
           </a:p>
           <a:p>
             <a:pPr lvl="1"/>
@@ -611,7 +605,6 @@
               <a:rPr lang="en-US" smtClean="0"/>
               <a:t>Second level</a:t>
             </a:r>
-            <a:endParaRPr lang="en-US" smtClean="0"/>
           </a:p>
           <a:p>
             <a:pPr lvl="2"/>
@@ -619,7 +612,6 @@
               <a:rPr lang="en-US" smtClean="0"/>
               <a:t>Third level</a:t>
             </a:r>
-            <a:endParaRPr lang="en-US" smtClean="0"/>
           </a:p>
           <a:p>
             <a:pPr lvl="3"/>
@@ -627,7 +619,6 @@
               <a:rPr lang="en-US" smtClean="0"/>
               <a:t>Fourth level</a:t>
             </a:r>
-            <a:endParaRPr lang="en-US" smtClean="0"/>
           </a:p>
           <a:p>
             <a:pPr lvl="4"/>
@@ -656,6 +647,7 @@
           <a:p>
             <a:fld id="{5BCAD085-E8A6-8845-BD4E-CB4CCA059FC4}" type="datetimeFigureOut">
               <a:rPr lang="en-US" smtClean="0"/>
+              <a:t>1/27/13</a:t>
             </a:fld>
             <a:endParaRPr lang="en-US"/>
           </a:p>
@@ -697,12 +689,18 @@
           <a:p>
             <a:fld id="{C1FF6DA9-008F-8B48-92A6-B652298478BF}" type="slidenum">
               <a:rPr lang="en-US" smtClean="0"/>
+              <a:t>‹#›</a:t>
             </a:fld>
             <a:endParaRPr lang="en-US"/>
           </a:p>
         </p:txBody>
       </p:sp>
     </p:spTree>
+    <p:extLst>
+      <p:ext uri="{BB962C8B-B14F-4D97-AF65-F5344CB8AC3E}">
+        <p14:creationId xmlns:p14="http://schemas.microsoft.com/office/powerpoint/2010/main" val="3612223792"/>
+      </p:ext>
+    </p:extLst>
   </p:cSld>
   <p:clrMapOvr>
     <a:masterClrMapping/>
@@ -770,7 +768,6 @@
               <a:rPr lang="en-US" smtClean="0"/>
               <a:t>Click to edit Master text styles</a:t>
             </a:r>
-            <a:endParaRPr lang="en-US" smtClean="0"/>
           </a:p>
           <a:p>
             <a:pPr lvl="1"/>
@@ -778,7 +775,6 @@
               <a:rPr lang="en-US" smtClean="0"/>
               <a:t>Second level</a:t>
             </a:r>
-            <a:endParaRPr lang="en-US" smtClean="0"/>
           </a:p>
           <a:p>
             <a:pPr lvl="2"/>
@@ -786,7 +782,6 @@
               <a:rPr lang="en-US" smtClean="0"/>
               <a:t>Third level</a:t>
             </a:r>
-            <a:endParaRPr lang="en-US" smtClean="0"/>
           </a:p>
           <a:p>
             <a:pPr lvl="3"/>
@@ -794,7 +789,6 @@
               <a:rPr lang="en-US" smtClean="0"/>
               <a:t>Fourth level</a:t>
             </a:r>
-            <a:endParaRPr lang="en-US" smtClean="0"/>
           </a:p>
           <a:p>
             <a:pPr lvl="4"/>
@@ -823,6 +817,7 @@
           <a:p>
             <a:fld id="{5BCAD085-E8A6-8845-BD4E-CB4CCA059FC4}" type="datetimeFigureOut">
               <a:rPr lang="en-US" smtClean="0"/>
+              <a:t>1/27/13</a:t>
             </a:fld>
             <a:endParaRPr lang="en-US"/>
           </a:p>
@@ -864,12 +859,18 @@
           <a:p>
             <a:fld id="{C1FF6DA9-008F-8B48-92A6-B652298478BF}" type="slidenum">
               <a:rPr lang="en-US" smtClean="0"/>
+              <a:t>‹#›</a:t>
             </a:fld>
             <a:endParaRPr lang="en-US"/>
           </a:p>
         </p:txBody>
       </p:sp>
     </p:spTree>
+    <p:extLst>
+      <p:ext uri="{BB962C8B-B14F-4D97-AF65-F5344CB8AC3E}">
+        <p14:creationId xmlns:p14="http://schemas.microsoft.com/office/powerpoint/2010/main" val="2614314258"/>
+      </p:ext>
+    </p:extLst>
   </p:cSld>
   <p:clrMapOvr>
     <a:masterClrMapping/>
@@ -1042,7 +1043,6 @@
               <a:rPr lang="en-US" smtClean="0"/>
               <a:t>Click to edit Master text styles</a:t>
             </a:r>
-            <a:endParaRPr lang="en-US" smtClean="0"/>
           </a:p>
         </p:txBody>
       </p:sp>
@@ -1063,6 +1063,7 @@
           <a:p>
             <a:fld id="{5BCAD085-E8A6-8845-BD4E-CB4CCA059FC4}" type="datetimeFigureOut">
               <a:rPr lang="en-US" smtClean="0"/>
+              <a:t>1/27/13</a:t>
             </a:fld>
             <a:endParaRPr lang="en-US"/>
           </a:p>
@@ -1104,12 +1105,18 @@
           <a:p>
             <a:fld id="{C1FF6DA9-008F-8B48-92A6-B652298478BF}" type="slidenum">
               <a:rPr lang="en-US" smtClean="0"/>
+              <a:t>‹#›</a:t>
             </a:fld>
             <a:endParaRPr lang="en-US"/>
           </a:p>
         </p:txBody>
       </p:sp>
     </p:spTree>
+    <p:extLst>
+      <p:ext uri="{BB962C8B-B14F-4D97-AF65-F5344CB8AC3E}">
+        <p14:creationId xmlns:p14="http://schemas.microsoft.com/office/powerpoint/2010/main" val="960648375"/>
+      </p:ext>
+    </p:extLst>
   </p:cSld>
   <p:clrMapOvr>
     <a:masterClrMapping/>
@@ -1210,7 +1217,6 @@
               <a:rPr lang="en-US" smtClean="0"/>
               <a:t>Click to edit Master text styles</a:t>
             </a:r>
-            <a:endParaRPr lang="en-US" smtClean="0"/>
           </a:p>
           <a:p>
             <a:pPr lvl="1"/>
@@ -1218,7 +1224,6 @@
               <a:rPr lang="en-US" smtClean="0"/>
               <a:t>Second level</a:t>
             </a:r>
-            <a:endParaRPr lang="en-US" smtClean="0"/>
           </a:p>
           <a:p>
             <a:pPr lvl="2"/>
@@ -1226,7 +1231,6 @@
               <a:rPr lang="en-US" smtClean="0"/>
               <a:t>Third level</a:t>
             </a:r>
-            <a:endParaRPr lang="en-US" smtClean="0"/>
           </a:p>
           <a:p>
             <a:pPr lvl="3"/>
@@ -1234,7 +1238,6 @@
               <a:rPr lang="en-US" smtClean="0"/>
               <a:t>Fourth level</a:t>
             </a:r>
-            <a:endParaRPr lang="en-US" smtClean="0"/>
           </a:p>
           <a:p>
             <a:pPr lvl="4"/>
@@ -1299,7 +1302,6 @@
               <a:rPr lang="en-US" smtClean="0"/>
               <a:t>Click to edit Master text styles</a:t>
             </a:r>
-            <a:endParaRPr lang="en-US" smtClean="0"/>
           </a:p>
           <a:p>
             <a:pPr lvl="1"/>
@@ -1307,7 +1309,6 @@
               <a:rPr lang="en-US" smtClean="0"/>
               <a:t>Second level</a:t>
             </a:r>
-            <a:endParaRPr lang="en-US" smtClean="0"/>
           </a:p>
           <a:p>
             <a:pPr lvl="2"/>
@@ -1315,7 +1316,6 @@
               <a:rPr lang="en-US" smtClean="0"/>
               <a:t>Third level</a:t>
             </a:r>
-            <a:endParaRPr lang="en-US" smtClean="0"/>
           </a:p>
           <a:p>
             <a:pPr lvl="3"/>
@@ -1323,7 +1323,6 @@
               <a:rPr lang="en-US" smtClean="0"/>
               <a:t>Fourth level</a:t>
             </a:r>
-            <a:endParaRPr lang="en-US" smtClean="0"/>
           </a:p>
           <a:p>
             <a:pPr lvl="4"/>
@@ -1352,6 +1351,7 @@
           <a:p>
             <a:fld id="{5BCAD085-E8A6-8845-BD4E-CB4CCA059FC4}" type="datetimeFigureOut">
               <a:rPr lang="en-US" smtClean="0"/>
+              <a:t>1/27/13</a:t>
             </a:fld>
             <a:endParaRPr lang="en-US"/>
           </a:p>
@@ -1393,12 +1393,18 @@
           <a:p>
             <a:fld id="{C1FF6DA9-008F-8B48-92A6-B652298478BF}" type="slidenum">
               <a:rPr lang="en-US" smtClean="0"/>
+              <a:t>‹#›</a:t>
             </a:fld>
             <a:endParaRPr lang="en-US"/>
           </a:p>
         </p:txBody>
       </p:sp>
     </p:spTree>
+    <p:extLst>
+      <p:ext uri="{BB962C8B-B14F-4D97-AF65-F5344CB8AC3E}">
+        <p14:creationId xmlns:p14="http://schemas.microsoft.com/office/powerpoint/2010/main" val="2782244947"/>
+      </p:ext>
+    </p:extLst>
   </p:cSld>
   <p:clrMapOvr>
     <a:masterClrMapping/>
@@ -1512,7 +1518,6 @@
               <a:rPr lang="en-US" smtClean="0"/>
               <a:t>Click to edit Master text styles</a:t>
             </a:r>
-            <a:endParaRPr lang="en-US" smtClean="0"/>
           </a:p>
         </p:txBody>
       </p:sp>
@@ -1569,7 +1574,6 @@
               <a:rPr lang="en-US" smtClean="0"/>
               <a:t>Click to edit Master text styles</a:t>
             </a:r>
-            <a:endParaRPr lang="en-US" smtClean="0"/>
           </a:p>
           <a:p>
             <a:pPr lvl="1"/>
@@ -1577,7 +1581,6 @@
               <a:rPr lang="en-US" smtClean="0"/>
               <a:t>Second level</a:t>
             </a:r>
-            <a:endParaRPr lang="en-US" smtClean="0"/>
           </a:p>
           <a:p>
             <a:pPr lvl="2"/>
@@ -1585,7 +1588,6 @@
               <a:rPr lang="en-US" smtClean="0"/>
               <a:t>Third level</a:t>
             </a:r>
-            <a:endParaRPr lang="en-US" smtClean="0"/>
           </a:p>
           <a:p>
             <a:pPr lvl="3"/>
@@ -1593,7 +1595,6 @@
               <a:rPr lang="en-US" smtClean="0"/>
               <a:t>Fourth level</a:t>
             </a:r>
-            <a:endParaRPr lang="en-US" smtClean="0"/>
           </a:p>
           <a:p>
             <a:pPr lvl="4"/>
@@ -1667,7 +1668,6 @@
               <a:rPr lang="en-US" smtClean="0"/>
               <a:t>Click to edit Master text styles</a:t>
             </a:r>
-            <a:endParaRPr lang="en-US" smtClean="0"/>
           </a:p>
         </p:txBody>
       </p:sp>
@@ -1724,7 +1724,6 @@
               <a:rPr lang="en-US" smtClean="0"/>
               <a:t>Click to edit Master text styles</a:t>
             </a:r>
-            <a:endParaRPr lang="en-US" smtClean="0"/>
           </a:p>
           <a:p>
             <a:pPr lvl="1"/>
@@ -1732,7 +1731,6 @@
               <a:rPr lang="en-US" smtClean="0"/>
               <a:t>Second level</a:t>
             </a:r>
-            <a:endParaRPr lang="en-US" smtClean="0"/>
           </a:p>
           <a:p>
             <a:pPr lvl="2"/>
@@ -1740,7 +1738,6 @@
               <a:rPr lang="en-US" smtClean="0"/>
               <a:t>Third level</a:t>
             </a:r>
-            <a:endParaRPr lang="en-US" smtClean="0"/>
           </a:p>
           <a:p>
             <a:pPr lvl="3"/>
@@ -1748,7 +1745,6 @@
               <a:rPr lang="en-US" smtClean="0"/>
               <a:t>Fourth level</a:t>
             </a:r>
-            <a:endParaRPr lang="en-US" smtClean="0"/>
           </a:p>
           <a:p>
             <a:pPr lvl="4"/>
@@ -1777,6 +1773,7 @@
           <a:p>
             <a:fld id="{5BCAD085-E8A6-8845-BD4E-CB4CCA059FC4}" type="datetimeFigureOut">
               <a:rPr lang="en-US" smtClean="0"/>
+              <a:t>1/27/13</a:t>
             </a:fld>
             <a:endParaRPr lang="en-US"/>
           </a:p>
@@ -1818,12 +1815,18 @@
           <a:p>
             <a:fld id="{C1FF6DA9-008F-8B48-92A6-B652298478BF}" type="slidenum">
               <a:rPr lang="en-US" smtClean="0"/>
+              <a:t>‹#›</a:t>
             </a:fld>
             <a:endParaRPr lang="en-US"/>
           </a:p>
         </p:txBody>
       </p:sp>
     </p:spTree>
+    <p:extLst>
+      <p:ext uri="{BB962C8B-B14F-4D97-AF65-F5344CB8AC3E}">
+        <p14:creationId xmlns:p14="http://schemas.microsoft.com/office/powerpoint/2010/main" val="990158736"/>
+      </p:ext>
+    </p:extLst>
   </p:cSld>
   <p:clrMapOvr>
     <a:masterClrMapping/>
@@ -1888,6 +1891,7 @@
           <a:p>
             <a:fld id="{5BCAD085-E8A6-8845-BD4E-CB4CCA059FC4}" type="datetimeFigureOut">
               <a:rPr lang="en-US" smtClean="0"/>
+              <a:t>1/27/13</a:t>
             </a:fld>
             <a:endParaRPr lang="en-US"/>
           </a:p>
@@ -1929,12 +1933,18 @@
           <a:p>
             <a:fld id="{C1FF6DA9-008F-8B48-92A6-B652298478BF}" type="slidenum">
               <a:rPr lang="en-US" smtClean="0"/>
+              <a:t>‹#›</a:t>
             </a:fld>
             <a:endParaRPr lang="en-US"/>
           </a:p>
         </p:txBody>
       </p:sp>
     </p:spTree>
+    <p:extLst>
+      <p:ext uri="{BB962C8B-B14F-4D97-AF65-F5344CB8AC3E}">
+        <p14:creationId xmlns:p14="http://schemas.microsoft.com/office/powerpoint/2010/main" val="727027711"/>
+      </p:ext>
+    </p:extLst>
   </p:cSld>
   <p:clrMapOvr>
     <a:masterClrMapping/>
@@ -1976,6 +1986,7 @@
           <a:p>
             <a:fld id="{5BCAD085-E8A6-8845-BD4E-CB4CCA059FC4}" type="datetimeFigureOut">
               <a:rPr lang="en-US" smtClean="0"/>
+              <a:t>1/27/13</a:t>
             </a:fld>
             <a:endParaRPr lang="en-US"/>
           </a:p>
@@ -2017,12 +2028,18 @@
           <a:p>
             <a:fld id="{C1FF6DA9-008F-8B48-92A6-B652298478BF}" type="slidenum">
               <a:rPr lang="en-US" smtClean="0"/>
+              <a:t>‹#›</a:t>
             </a:fld>
             <a:endParaRPr lang="en-US"/>
           </a:p>
         </p:txBody>
       </p:sp>
     </p:spTree>
+    <p:extLst>
+      <p:ext uri="{BB962C8B-B14F-4D97-AF65-F5344CB8AC3E}">
+        <p14:creationId xmlns:p14="http://schemas.microsoft.com/office/powerpoint/2010/main" val="1212999818"/>
+      </p:ext>
+    </p:extLst>
   </p:cSld>
   <p:clrMapOvr>
     <a:masterClrMapping/>
@@ -2132,7 +2149,6 @@
               <a:rPr lang="en-US" smtClean="0"/>
               <a:t>Click to edit Master text styles</a:t>
             </a:r>
-            <a:endParaRPr lang="en-US" smtClean="0"/>
           </a:p>
           <a:p>
             <a:pPr lvl="1"/>
@@ -2140,7 +2156,6 @@
               <a:rPr lang="en-US" smtClean="0"/>
               <a:t>Second level</a:t>
             </a:r>
-            <a:endParaRPr lang="en-US" smtClean="0"/>
           </a:p>
           <a:p>
             <a:pPr lvl="2"/>
@@ -2148,7 +2163,6 @@
               <a:rPr lang="en-US" smtClean="0"/>
               <a:t>Third level</a:t>
             </a:r>
-            <a:endParaRPr lang="en-US" smtClean="0"/>
           </a:p>
           <a:p>
             <a:pPr lvl="3"/>
@@ -2156,7 +2170,6 @@
               <a:rPr lang="en-US" smtClean="0"/>
               <a:t>Fourth level</a:t>
             </a:r>
-            <a:endParaRPr lang="en-US" smtClean="0"/>
           </a:p>
           <a:p>
             <a:pPr lvl="4"/>
@@ -2230,7 +2243,6 @@
               <a:rPr lang="en-US" smtClean="0"/>
               <a:t>Click to edit Master text styles</a:t>
             </a:r>
-            <a:endParaRPr lang="en-US" smtClean="0"/>
           </a:p>
         </p:txBody>
       </p:sp>
@@ -2251,6 +2263,7 @@
           <a:p>
             <a:fld id="{5BCAD085-E8A6-8845-BD4E-CB4CCA059FC4}" type="datetimeFigureOut">
               <a:rPr lang="en-US" smtClean="0"/>
+              <a:t>1/27/13</a:t>
             </a:fld>
             <a:endParaRPr lang="en-US"/>
           </a:p>
@@ -2292,12 +2305,18 @@
           <a:p>
             <a:fld id="{C1FF6DA9-008F-8B48-92A6-B652298478BF}" type="slidenum">
               <a:rPr lang="en-US" smtClean="0"/>
+              <a:t>‹#›</a:t>
             </a:fld>
             <a:endParaRPr lang="en-US"/>
           </a:p>
         </p:txBody>
       </p:sp>
     </p:spTree>
+    <p:extLst>
+      <p:ext uri="{BB962C8B-B14F-4D97-AF65-F5344CB8AC3E}">
+        <p14:creationId xmlns:p14="http://schemas.microsoft.com/office/powerpoint/2010/main" val="1840726560"/>
+      </p:ext>
+    </p:extLst>
   </p:cSld>
   <p:clrMapOvr>
     <a:masterClrMapping/>
@@ -2477,7 +2496,6 @@
               <a:rPr lang="en-US" smtClean="0"/>
               <a:t>Click to edit Master text styles</a:t>
             </a:r>
-            <a:endParaRPr lang="en-US" smtClean="0"/>
           </a:p>
         </p:txBody>
       </p:sp>
@@ -2498,6 +2516,7 @@
           <a:p>
             <a:fld id="{5BCAD085-E8A6-8845-BD4E-CB4CCA059FC4}" type="datetimeFigureOut">
               <a:rPr lang="en-US" smtClean="0"/>
+              <a:t>1/27/13</a:t>
             </a:fld>
             <a:endParaRPr lang="en-US"/>
           </a:p>
@@ -2539,12 +2558,18 @@
           <a:p>
             <a:fld id="{C1FF6DA9-008F-8B48-92A6-B652298478BF}" type="slidenum">
               <a:rPr lang="en-US" smtClean="0"/>
+              <a:t>‹#›</a:t>
             </a:fld>
             <a:endParaRPr lang="en-US"/>
           </a:p>
         </p:txBody>
       </p:sp>
     </p:spTree>
+    <p:extLst>
+      <p:ext uri="{BB962C8B-B14F-4D97-AF65-F5344CB8AC3E}">
+        <p14:creationId xmlns:p14="http://schemas.microsoft.com/office/powerpoint/2010/main" val="3889236939"/>
+      </p:ext>
+    </p:extLst>
   </p:cSld>
   <p:clrMapOvr>
     <a:masterClrMapping/>
@@ -2637,7 +2662,6 @@
               <a:rPr lang="en-US" smtClean="0"/>
               <a:t>Click to edit Master text styles</a:t>
             </a:r>
-            <a:endParaRPr lang="en-US" smtClean="0"/>
           </a:p>
           <a:p>
             <a:pPr lvl="1"/>
@@ -2645,7 +2669,6 @@
               <a:rPr lang="en-US" smtClean="0"/>
               <a:t>Second level</a:t>
             </a:r>
-            <a:endParaRPr lang="en-US" smtClean="0"/>
           </a:p>
           <a:p>
             <a:pPr lvl="2"/>
@@ -2653,7 +2676,6 @@
               <a:rPr lang="en-US" smtClean="0"/>
               <a:t>Third level</a:t>
             </a:r>
-            <a:endParaRPr lang="en-US" smtClean="0"/>
           </a:p>
           <a:p>
             <a:pPr lvl="3"/>
@@ -2661,7 +2683,6 @@
               <a:rPr lang="en-US" smtClean="0"/>
               <a:t>Fourth level</a:t>
             </a:r>
-            <a:endParaRPr lang="en-US" smtClean="0"/>
           </a:p>
           <a:p>
             <a:pPr lvl="4"/>
@@ -2708,6 +2729,7 @@
           <a:p>
             <a:fld id="{5BCAD085-E8A6-8845-BD4E-CB4CCA059FC4}" type="datetimeFigureOut">
               <a:rPr lang="en-US" smtClean="0"/>
+              <a:t>1/27/13</a:t>
             </a:fld>
             <a:endParaRPr lang="en-US"/>
           </a:p>
@@ -2785,12 +2807,18 @@
           <a:p>
             <a:fld id="{C1FF6DA9-008F-8B48-92A6-B652298478BF}" type="slidenum">
               <a:rPr lang="en-US" smtClean="0"/>
+              <a:t>‹#›</a:t>
             </a:fld>
             <a:endParaRPr lang="en-US"/>
           </a:p>
         </p:txBody>
       </p:sp>
     </p:spTree>
+    <p:extLst>
+      <p:ext uri="{BB962C8B-B14F-4D97-AF65-F5344CB8AC3E}">
+        <p14:creationId xmlns:p14="http://schemas.microsoft.com/office/powerpoint/2010/main" val="2209977519"/>
+      </p:ext>
+    </p:extLst>
   </p:cSld>
   <p:clrMap bg1="lt1" tx1="dk1" bg2="lt2" tx2="dk2" accent1="accent1" accent2="accent2" accent3="accent3" accent4="accent4" accent5="accent5" accent6="accent6" hlink="hlink" folHlink="folHlink"/>
   <p:sldLayoutIdLst>
@@ -2828,7 +2856,7 @@
         <a:spcBef>
           <a:spcPct val="20000"/>
         </a:spcBef>
-        <a:buFont typeface="Arial" panose="020B0604020202020204"/>
+        <a:buFont typeface="Arial"/>
         <a:buChar char="•"/>
         <a:defRPr sz="3200" kern="1200">
           <a:solidFill>
@@ -2843,7 +2871,7 @@
         <a:spcBef>
           <a:spcPct val="20000"/>
         </a:spcBef>
-        <a:buFont typeface="Arial" panose="020B0604020202020204"/>
+        <a:buFont typeface="Arial"/>
         <a:buChar char="–"/>
         <a:defRPr sz="2800" kern="1200">
           <a:solidFill>
@@ -2858,7 +2886,7 @@
         <a:spcBef>
           <a:spcPct val="20000"/>
         </a:spcBef>
-        <a:buFont typeface="Arial" panose="020B0604020202020204"/>
+        <a:buFont typeface="Arial"/>
         <a:buChar char="•"/>
         <a:defRPr sz="2400" kern="1200">
           <a:solidFill>
@@ -2873,7 +2901,7 @@
         <a:spcBef>
           <a:spcPct val="20000"/>
         </a:spcBef>
-        <a:buFont typeface="Arial" panose="020B0604020202020204"/>
+        <a:buFont typeface="Arial"/>
         <a:buChar char="–"/>
         <a:defRPr sz="2000" kern="1200">
           <a:solidFill>
@@ -2888,7 +2916,7 @@
         <a:spcBef>
           <a:spcPct val="20000"/>
         </a:spcBef>
-        <a:buFont typeface="Arial" panose="020B0604020202020204"/>
+        <a:buFont typeface="Arial"/>
         <a:buChar char="»"/>
         <a:defRPr sz="2000" kern="1200">
           <a:solidFill>
@@ -2903,7 +2931,7 @@
         <a:spcBef>
           <a:spcPct val="20000"/>
         </a:spcBef>
-        <a:buFont typeface="Arial" panose="020B0604020202020204"/>
+        <a:buFont typeface="Arial"/>
         <a:buChar char="•"/>
         <a:defRPr sz="2000" kern="1200">
           <a:solidFill>
@@ -2918,7 +2946,7 @@
         <a:spcBef>
           <a:spcPct val="20000"/>
         </a:spcBef>
-        <a:buFont typeface="Arial" panose="020B0604020202020204"/>
+        <a:buFont typeface="Arial"/>
         <a:buChar char="•"/>
         <a:defRPr sz="2000" kern="1200">
           <a:solidFill>
@@ -2933,7 +2961,7 @@
         <a:spcBef>
           <a:spcPct val="20000"/>
         </a:spcBef>
-        <a:buFont typeface="Arial" panose="020B0604020202020204"/>
+        <a:buFont typeface="Arial"/>
         <a:buChar char="•"/>
         <a:defRPr sz="2000" kern="1200">
           <a:solidFill>
@@ -2948,7 +2976,7 @@
         <a:spcBef>
           <a:spcPct val="20000"/>
         </a:spcBef>
-        <a:buFont typeface="Arial" panose="020B0604020202020204"/>
+        <a:buFont typeface="Arial"/>
         <a:buChar char="•"/>
         <a:defRPr sz="2000" kern="1200">
           <a:solidFill>
@@ -3060,7 +3088,7 @@
 </file>
 
 <file path=ppt/slides/slide1.xml><?xml version="1.0" encoding="utf-8"?>
-<p:sld xmlns:a="http://schemas.openxmlformats.org/drawingml/2006/main" xmlns:r="http://schemas.openxmlformats.org/officeDocument/2006/relationships" xmlns:p="http://schemas.openxmlformats.org/presentationml/2006/main">
+<p:sld xmlns:a="http://schemas.openxmlformats.org/drawingml/2006/main" xmlns:p="http://schemas.openxmlformats.org/presentationml/2006/main" xmlns:r="http://schemas.openxmlformats.org/officeDocument/2006/relationships">
   <p:cSld>
     <p:spTree>
       <p:nvGrpSpPr>
@@ -3106,12 +3134,91 @@
           <a:lstStyle/>
           <a:p>
             <a:r>
-              <a:t>基于 ResNet50 + CBAM 的花卉图像分类</a:t>
-            </a:r>
-          </a:p>
-          <a:p>
-            <a:r>
-              <a:t>自动生成时间：2026-05-27</a:t>
+              <a:t>基于 ResNet50 + CBAM 的叶片图像分类</a:t>
+            </a:r>
+          </a:p>
+          <a:p>
+            <a:r>
+              <a:t>自动生成时间：2026-05-29</a:t>
+            </a:r>
+          </a:p>
+        </p:txBody>
+      </p:sp>
+    </p:spTree>
+  </p:cSld>
+  <p:clrMapOvr>
+    <a:masterClrMapping/>
+  </p:clrMapOvr>
+</p:sld>
+</file>
+
+<file path=ppt/slides/slide10.xml><?xml version="1.0" encoding="utf-8"?>
+<p:sld xmlns:a="http://schemas.openxmlformats.org/drawingml/2006/main" xmlns:p="http://schemas.openxmlformats.org/presentationml/2006/main" xmlns:r="http://schemas.openxmlformats.org/officeDocument/2006/relationships">
+  <p:cSld>
+    <p:spTree>
+      <p:nvGrpSpPr>
+        <p:cNvPr id="1" name=""/>
+        <p:cNvGrpSpPr/>
+        <p:nvPr/>
+      </p:nvGrpSpPr>
+      <p:grpSpPr/>
+      <p:sp>
+        <p:nvSpPr>
+          <p:cNvPr id="2" name="Title 1"/>
+          <p:cNvSpPr>
+            <a:spLocks noGrp="1"/>
+          </p:cNvSpPr>
+          <p:nvPr>
+            <p:ph type="title"/>
+          </p:nvPr>
+        </p:nvSpPr>
+        <p:spPr/>
+        <p:txBody>
+          <a:bodyPr/>
+          <a:lstStyle/>
+          <a:p>
+            <a:r>
+              <a:t>小组分工（按实际替换）</a:t>
+            </a:r>
+          </a:p>
+        </p:txBody>
+      </p:sp>
+      <p:sp>
+        <p:nvSpPr>
+          <p:cNvPr id="3" name="Content Placeholder 2"/>
+          <p:cNvSpPr>
+            <a:spLocks noGrp="1"/>
+          </p:cNvSpPr>
+          <p:nvPr>
+            <p:ph idx="1"/>
+          </p:nvPr>
+        </p:nvSpPr>
+        <p:spPr/>
+        <p:txBody>
+          <a:bodyPr/>
+          <a:lstStyle/>
+          <a:p>
+            <a:pPr>
+              <a:defRPr sz="2000"/>
+            </a:pPr>
+            <a:r>
+              <a:t>组长：方案设计、进度管理、答辩统筹</a:t>
+            </a:r>
+          </a:p>
+          <a:p>
+            <a:pPr>
+              <a:defRPr sz="2000"/>
+            </a:pPr>
+            <a:r>
+              <a:t>组员1：数据准备、训练调参、实验复现</a:t>
+            </a:r>
+          </a:p>
+          <a:p>
+            <a:pPr>
+              <a:defRPr sz="2000"/>
+            </a:pPr>
+            <a:r>
+              <a:t>组员2：报告撰写、PPT制作、路演讲解</a:t>
             </a:r>
           </a:p>
         </p:txBody>
@@ -3125,7 +3232,7 @@
 </file>
 
 <file path=ppt/slides/slide2.xml><?xml version="1.0" encoding="utf-8"?>
-<p:sld xmlns:a="http://schemas.openxmlformats.org/drawingml/2006/main" xmlns:r="http://schemas.openxmlformats.org/officeDocument/2006/relationships" xmlns:p="http://schemas.openxmlformats.org/presentationml/2006/main">
+<p:sld xmlns:a="http://schemas.openxmlformats.org/drawingml/2006/main" xmlns:p="http://schemas.openxmlformats.org/presentationml/2006/main" xmlns:r="http://schemas.openxmlformats.org/officeDocument/2006/relationships">
   <p:cSld>
     <p:spTree>
       <p:nvGrpSpPr>
@@ -3204,7 +3311,7 @@
 </file>
 
 <file path=ppt/slides/slide3.xml><?xml version="1.0" encoding="utf-8"?>
-<p:sld xmlns:a="http://schemas.openxmlformats.org/drawingml/2006/main" xmlns:r="http://schemas.openxmlformats.org/officeDocument/2006/relationships" xmlns:p="http://schemas.openxmlformats.org/presentationml/2006/main">
+<p:sld xmlns:a="http://schemas.openxmlformats.org/drawingml/2006/main" xmlns:p="http://schemas.openxmlformats.org/presentationml/2006/main" xmlns:r="http://schemas.openxmlformats.org/officeDocument/2006/relationships">
   <p:cSld>
     <p:spTree>
       <p:nvGrpSpPr>
@@ -3253,7 +3360,7 @@
               <a:defRPr sz="2000"/>
             </a:pPr>
             <a:r>
-              <a:t>数据源：TensorFlow Flowers（公开数据集）</a:t>
+              <a:t>数据源：PlantVillage（公开叶片数据集）</a:t>
             </a:r>
           </a:p>
           <a:p>
@@ -3261,7 +3368,7 @@
               <a:defRPr sz="2000"/>
             </a:pPr>
             <a:r>
-              <a:t>类别数：5（daisy, dandelion, roses, sunflowers, tulips）</a:t>
+              <a:t>类别数：5（Orange___Haunglongbing_(Citrus_greening), Tomato___Tomato_Yellow_Leaf_Curl_Virus, Soybean___healthy, Peach___Bacterial_spot, Tomato___Bacterial_spot）</a:t>
             </a:r>
           </a:p>
           <a:p>
@@ -3277,35 +3384,11 @@
               <a:defRPr sz="2000"/>
             </a:pPr>
             <a:r>
-              <a:t>图像特点：自然场景、视角多样、背景干扰明显</a:t>
-            </a:r>
-          </a:p>
-        </p:txBody>
-      </p:sp>
-      <p:pic>
-        <p:nvPicPr>
-          <p:cNvPr id="4" name="Picture 3" descr="class_distribution.png"/>
-          <p:cNvPicPr>
-            <a:picLocks noChangeAspect="1"/>
-          </p:cNvPicPr>
-          <p:nvPr/>
-        </p:nvPicPr>
-        <p:blipFill>
-          <a:blip r:embed="rId1"/>
-          <a:stretch>
-            <a:fillRect/>
-          </a:stretch>
-        </p:blipFill>
-        <p:spPr>
-          <a:xfrm>
-            <a:off x="6400800" y="1463040"/>
-            <a:ext cx="5394960" cy="1798320"/>
-          </a:xfrm>
-          <a:prstGeom prst="rect">
-            <a:avLst/>
-          </a:prstGeom>
-        </p:spPr>
-      </p:pic>
+              <a:t>图像特点：叶片病害特征明显、纹理与斑点细节重要</a:t>
+            </a:r>
+          </a:p>
+        </p:txBody>
+      </p:sp>
     </p:spTree>
   </p:cSld>
   <p:clrMapOvr>
@@ -3315,7 +3398,7 @@
 </file>
 
 <file path=ppt/slides/slide4.xml><?xml version="1.0" encoding="utf-8"?>
-<p:sld xmlns:a="http://schemas.openxmlformats.org/drawingml/2006/main" xmlns:r="http://schemas.openxmlformats.org/officeDocument/2006/relationships" xmlns:p="http://schemas.openxmlformats.org/presentationml/2006/main">
+<p:sld xmlns:a="http://schemas.openxmlformats.org/drawingml/2006/main" xmlns:p="http://schemas.openxmlformats.org/presentationml/2006/main" xmlns:r="http://schemas.openxmlformats.org/officeDocument/2006/relationships">
   <p:cSld>
     <p:spTree>
       <p:nvGrpSpPr>
@@ -3402,7 +3485,7 @@
 </file>
 
 <file path=ppt/slides/slide5.xml><?xml version="1.0" encoding="utf-8"?>
-<p:sld xmlns:a="http://schemas.openxmlformats.org/drawingml/2006/main" xmlns:r="http://schemas.openxmlformats.org/officeDocument/2006/relationships" xmlns:p="http://schemas.openxmlformats.org/presentationml/2006/main">
+<p:sld xmlns:a="http://schemas.openxmlformats.org/drawingml/2006/main" xmlns:p="http://schemas.openxmlformats.org/presentationml/2006/main" xmlns:r="http://schemas.openxmlformats.org/officeDocument/2006/relationships">
   <p:cSld>
     <p:spTree>
       <p:nvGrpSpPr>
@@ -3489,7 +3572,7 @@
 </file>
 
 <file path=ppt/slides/slide6.xml><?xml version="1.0" encoding="utf-8"?>
-<p:sld xmlns:a="http://schemas.openxmlformats.org/drawingml/2006/main" xmlns:r="http://schemas.openxmlformats.org/officeDocument/2006/relationships" xmlns:p="http://schemas.openxmlformats.org/presentationml/2006/main">
+<p:sld xmlns:a="http://schemas.openxmlformats.org/drawingml/2006/main" xmlns:p="http://schemas.openxmlformats.org/presentationml/2006/main" xmlns:r="http://schemas.openxmlformats.org/officeDocument/2006/relationships">
   <p:cSld>
     <p:spTree>
       <p:nvGrpSpPr>
@@ -3612,7 +3695,7 @@
                     <a:lstStyle/>
                     <a:p>
                       <a:r>
-                        <a:t>88.67%</a:t>
+                        <a:t>84.00%</a:t>
                       </a:r>
                     </a:p>
                   </a:txBody>
@@ -3624,7 +3707,7 @@
                     <a:lstStyle/>
                     <a:p>
                       <a:r>
-                        <a:t>0.3251</a:t>
+                        <a:t>0.5405</a:t>
                       </a:r>
                     </a:p>
                   </a:txBody>
@@ -3662,7 +3745,7 @@
                     <a:lstStyle/>
                     <a:p>
                       <a:r>
-                        <a:t>88.00%</a:t>
+                        <a:t>84.00%</a:t>
                       </a:r>
                     </a:p>
                   </a:txBody>
@@ -3674,7 +3757,7 @@
                     <a:lstStyle/>
                     <a:p>
                       <a:r>
-                        <a:t>0.3920</a:t>
+                        <a:t>0.5127</a:t>
                       </a:r>
                     </a:p>
                   </a:txBody>
@@ -3712,7 +3795,7 @@
                     <a:lstStyle/>
                     <a:p>
                       <a:r>
-                        <a:t>88.00%</a:t>
+                        <a:t>64.00%</a:t>
                       </a:r>
                     </a:p>
                   </a:txBody>
@@ -3724,7 +3807,7 @@
                     <a:lstStyle/>
                     <a:p>
                       <a:r>
-                        <a:t>0.4960</a:t>
+                        <a:t>1.5305</a:t>
                       </a:r>
                     </a:p>
                   </a:txBody>
@@ -3762,7 +3845,7 @@
                     <a:lstStyle/>
                     <a:p>
                       <a:r>
-                        <a:t>84.00%</a:t>
+                        <a:t>76.00%</a:t>
                       </a:r>
                     </a:p>
                   </a:txBody>
@@ -3774,7 +3857,7 @@
                     <a:lstStyle/>
                     <a:p>
                       <a:r>
-                        <a:t>0.8292</a:t>
+                        <a:t>1.5348</a:t>
                       </a:r>
                     </a:p>
                   </a:txBody>
@@ -3806,7 +3889,7 @@
 </file>
 
 <file path=ppt/slides/slide7.xml><?xml version="1.0" encoding="utf-8"?>
-<p:sld xmlns:a="http://schemas.openxmlformats.org/drawingml/2006/main" xmlns:r="http://schemas.openxmlformats.org/officeDocument/2006/relationships" xmlns:p="http://schemas.openxmlformats.org/presentationml/2006/main">
+<p:sld xmlns:a="http://schemas.openxmlformats.org/drawingml/2006/main" xmlns:p="http://schemas.openxmlformats.org/presentationml/2006/main" xmlns:r="http://schemas.openxmlformats.org/officeDocument/2006/relationships">
   <p:cSld>
     <p:spTree>
       <p:nvGrpSpPr>
@@ -3836,54 +3919,6 @@
           </a:p>
         </p:txBody>
       </p:sp>
-      <p:pic>
-        <p:nvPicPr>
-          <p:cNvPr id="3" name="Picture 2" descr="accuracy_curve.png"/>
-          <p:cNvPicPr>
-            <a:picLocks noChangeAspect="1"/>
-          </p:cNvPicPr>
-          <p:nvPr/>
-        </p:nvPicPr>
-        <p:blipFill>
-          <a:blip r:embed="rId1"/>
-          <a:stretch>
-            <a:fillRect/>
-          </a:stretch>
-        </p:blipFill>
-        <p:spPr>
-          <a:xfrm>
-            <a:off x="548640" y="1188720"/>
-            <a:ext cx="5577840" cy="2788920"/>
-          </a:xfrm>
-          <a:prstGeom prst="rect">
-            <a:avLst/>
-          </a:prstGeom>
-        </p:spPr>
-      </p:pic>
-      <p:pic>
-        <p:nvPicPr>
-          <p:cNvPr id="4" name="Picture 3" descr="confusion_matrix.png"/>
-          <p:cNvPicPr>
-            <a:picLocks noChangeAspect="1"/>
-          </p:cNvPicPr>
-          <p:nvPr/>
-        </p:nvPicPr>
-        <p:blipFill>
-          <a:blip r:embed="rId2"/>
-          <a:stretch>
-            <a:fillRect/>
-          </a:stretch>
-        </p:blipFill>
-        <p:spPr>
-          <a:xfrm>
-            <a:off x="6217920" y="1188720"/>
-            <a:ext cx="5577840" cy="4462272"/>
-          </a:xfrm>
-          <a:prstGeom prst="rect">
-            <a:avLst/>
-          </a:prstGeom>
-        </p:spPr>
-      </p:pic>
     </p:spTree>
   </p:cSld>
   <p:clrMapOvr>
@@ -3893,7 +3928,7 @@
 </file>
 
 <file path=ppt/slides/slide8.xml><?xml version="1.0" encoding="utf-8"?>
-<p:sld xmlns:a="http://schemas.openxmlformats.org/drawingml/2006/main" xmlns:r="http://schemas.openxmlformats.org/officeDocument/2006/relationships" xmlns:p="http://schemas.openxmlformats.org/presentationml/2006/main">
+<p:sld xmlns:a="http://schemas.openxmlformats.org/drawingml/2006/main" xmlns:p="http://schemas.openxmlformats.org/presentationml/2006/main" xmlns:r="http://schemas.openxmlformats.org/officeDocument/2006/relationships">
   <p:cSld>
     <p:spTree>
       <p:nvGrpSpPr>
@@ -3942,7 +3977,7 @@
               <a:defRPr sz="2000"/>
             </a:pPr>
             <a:r>
-              <a:t>当前快速设置下最好模型：ResNet50 baseline（88.67%）</a:t>
+              <a:t>当前快速设置下最好模型：ResNet50 baseline（84.00%）</a:t>
             </a:r>
           </a:p>
           <a:p>
@@ -3980,7 +4015,7 @@
 </file>
 
 <file path=ppt/slides/slide9.xml><?xml version="1.0" encoding="utf-8"?>
-<p:sld xmlns:a="http://schemas.openxmlformats.org/drawingml/2006/main" xmlns:r="http://schemas.openxmlformats.org/officeDocument/2006/relationships" xmlns:p="http://schemas.openxmlformats.org/presentationml/2006/main">
+<p:sld xmlns:a="http://schemas.openxmlformats.org/drawingml/2006/main" xmlns:p="http://schemas.openxmlformats.org/presentationml/2006/main" xmlns:r="http://schemas.openxmlformats.org/officeDocument/2006/relationships">
   <p:cSld>
     <p:spTree>
       <p:nvGrpSpPr>
@@ -4374,10 +4409,6 @@
       </a:style>
     </a:lnDef>
   </a:objectDefaults>
-  <a:extLst>
-    <a:ext uri="{05A4C25C-085E-4340-85A3-A5531E510DB2}">
-      <thm15:themeFamily xmlns:thm15="http://schemas.microsoft.com/office/thememl/2012/main" name="Office Theme" id="{62F939B6-93AF-4DB8-9C6B-D6C7DFDC589F}" vid="{4A3C46E8-61CC-4603-A589-7422A47A8E4A}"/>
-    </a:ext>
-  </a:extLst>
+  <a:extraClrSchemeLst/>
 </a:theme>
 </file>
</xml_diff>